<commit_message>
docs: update WarriorFit_Technisch_NL presentation content
</commit_message>
<xml_diff>
--- a/documentation/WarriorFit_Technisch_NL.pptx
+++ b/documentation/WarriorFit_Technisch_NL.pptx
@@ -10250,40 +10250,6 @@
       </p:sp>
       <p:sp>
         <p:nvSpPr>
-          <p:cNvPr id="54" name="TextBox 53"/>
-          <p:cNvSpPr txBox="1"/>
-          <p:nvPr/>
-        </p:nvSpPr>
-        <p:spPr>
-          <a:xfrm>
-            <a:off x="4722733" y="3995000"/>
-            <a:ext cx="2004093" cy="490000"/>
-          </a:xfrm>
-          <a:prstGeom prst="rect">
-            <a:avLst/>
-          </a:prstGeom>
-          <a:noFill/>
-        </p:spPr>
-        <p:txBody>
-          <a:bodyPr wrap="square">
-            <a:spAutoFit/>
-          </a:bodyPr>
-          <a:lstStyle/>
-          <a:p>
-            <a:pPr algn="l"/>
-            <a:r>
-              <a:rPr sz="800" b="0">
-                <a:solidFill>
-                  <a:srgbClr val="334218"/>
-                </a:solidFill>
-              </a:rPr>
-              <a:t>Cross App · Status pagina  ·  Config per environment</a:t>
-            </a:r>
-          </a:p>
-        </p:txBody>
-      </p:sp>
-      <p:sp>
-        <p:nvSpPr>
           <p:cNvPr id="55" name="Rectangle 54"/>
           <p:cNvSpPr/>
           <p:nvPr/>
@@ -10469,40 +10435,6 @@
           <a:p>
             <a:pPr algn="ctr"/>
             <a:endParaRPr/>
-          </a:p>
-        </p:txBody>
-      </p:sp>
-      <p:sp>
-        <p:nvSpPr>
-          <p:cNvPr id="60" name="TextBox 59"/>
-          <p:cNvSpPr txBox="1"/>
-          <p:nvPr/>
-        </p:nvSpPr>
-        <p:spPr>
-          <a:xfrm>
-            <a:off x="6816826" y="4700000"/>
-            <a:ext cx="2004093" cy="490000"/>
-          </a:xfrm>
-          <a:prstGeom prst="rect">
-            <a:avLst/>
-          </a:prstGeom>
-          <a:noFill/>
-        </p:spPr>
-        <p:txBody>
-          <a:bodyPr wrap="square">
-            <a:spAutoFit/>
-          </a:bodyPr>
-          <a:lstStyle/>
-          <a:p>
-            <a:pPr algn="l"/>
-            <a:r>
-              <a:rPr sz="800" b="0">
-                <a:solidFill>
-                  <a:srgbClr val="F5F1E6"/>
-                </a:solidFill>
-              </a:rPr>
-              <a:t>Argon2id  ·  GDPR/AVG consent</a:t>
-            </a:r>
           </a:p>
         </p:txBody>
       </p:sp>

</xml_diff>